<commit_message>
docs(presentation): Replace day labels with topic labels
- Label slides by pipeline stage rather than day of the week
- Add clearly marked drafts for the three own-words explanations
</commit_message>
<xml_diff>
--- a/presentation/week1-review.pptx
+++ b/presentation/week1-review.pptx
@@ -1042,50 +1042,95 @@
           <a:lstStyle/>
           <a:p>
             <a:r>
-              <a:t>WRITE THIS YOURSELF BEFORE THE MEETING. Three or four sentences, in your voice,</a:t>
-            </a:r>
-          </a:p>
-          <a:p>
-            <a:r>
-              <a:t>replacing the placeholder line.</a:t>
+              <a:t>THIS IS A DRAFT, NOT YOUR ANSWER. Read it, then say the same idea your way and</a:t>
+            </a:r>
+          </a:p>
+          <a:p>
+            <a:r>
+              <a:t>replace the text. Ten minutes with it will do.</a:t>
             </a:r>
           </a:p>
           <a:p/>
           <a:p>
             <a:r>
-              <a:t>The bullets are your raw material, not the answer.</a:t>
+              <a:t>Why it must be yours: your mentor's self-check asks you to explain an embedding</a:t>
+            </a:r>
+          </a:p>
+          <a:p>
+            <a:r>
+              <a:t>without falling back on the word "vector", and he will ask a follow-up. The usual</a:t>
+            </a:r>
+          </a:p>
+          <a:p>
+            <a:r>
+              <a:t>ones are "so what makes two things land near each other?" and "why 384 numbers?"</a:t>
+            </a:r>
+          </a:p>
+          <a:p>
+            <a:r>
+              <a:t>Wording you did not write is exactly where those questions land badly.</a:t>
             </a:r>
           </a:p>
           <a:p/>
           <a:p>
             <a:r>
-              <a:t>A shape to react to and then discard: an embedding model reads text and hands</a:t>
-            </a:r>
-          </a:p>
-          <a:p>
-            <a:r>
-              <a:t>back coordinates on a map of meaning, where things that mean similar things sit</a:t>
-            </a:r>
-          </a:p>
-          <a:p>
-            <a:r>
-              <a:t>close together. Say it your own way. He will ask a follow-up question, and that</a:t>
-            </a:r>
-          </a:p>
-          <a:p>
-            <a:r>
-              <a:t>is exactly where borrowed wording collapses.</a:t>
+              <a:t>Answers worth having ready:</a:t>
+            </a:r>
+          </a:p>
+          <a:p>
+            <a:r>
+              <a:t>- What makes them land near each other? The model was trained on huge amounts of</a:t>
+            </a:r>
+          </a:p>
+          <a:p>
+            <a:r>
+              <a:t>  text and learned which words and phrases turn up in similar situations. Nobody</a:t>
+            </a:r>
+          </a:p>
+          <a:p>
+            <a:r>
+              <a:t>  programmed the positions.</a:t>
+            </a:r>
+          </a:p>
+          <a:p>
+            <a:r>
+              <a:t>- Why 384? That is just the size this particular model outputs. A bigger model</a:t>
+            </a:r>
+          </a:p>
+          <a:p>
+            <a:r>
+              <a:t>  uses more numbers and captures finer distinctions, at more cost. What matters is</a:t>
+            </a:r>
+          </a:p>
+          <a:p>
+            <a:r>
+              <a:t>  that the count never changes with the length of the input.</a:t>
+            </a:r>
+          </a:p>
+          <a:p>
+            <a:r>
+              <a:t>- Is it like a search index? No. A search index stores words. This stores a</a:t>
+            </a:r>
+          </a:p>
+          <a:p>
+            <a:r>
+              <a:t>  position, so two passages can be close together with no words in common.</a:t>
             </a:r>
           </a:p>
           <a:p/>
           <a:p>
             <a:r>
-              <a:t>If you genuinely run out of time, present the slide as unfinished and say so.</a:t>
-            </a:r>
-          </a:p>
-          <a:p>
-            <a:r>
-              <a:t>That is far better than reciting a sentence you cannot defend.</a:t>
+              <a:t>If you have not rewritten it by the morning, say so honestly - "this is my</a:t>
+            </a:r>
+          </a:p>
+          <a:p>
+            <a:r>
+              <a:t>current phrasing, I'm still tightening it" - and then demo the script. Showing</a:t>
+            </a:r>
+          </a:p>
+          <a:p>
+            <a:r>
+              <a:t>the 0.618 score live proves the understanding better than a polished sentence.</a:t>
             </a:r>
           </a:p>
         </p:txBody>
@@ -6639,7 +6684,7 @@
         <p:spPr>
           <a:xfrm>
             <a:off x="822960" y="566928"/>
-            <a:ext cx="1088136" cy="256032"/>
+            <a:ext cx="1389888" cy="256032"/>
           </a:xfrm>
           <a:prstGeom prst="rect">
             <a:avLst/>
@@ -6683,7 +6728,7 @@
         <p:spPr>
           <a:xfrm>
             <a:off x="822960" y="548640"/>
-            <a:ext cx="1088136" cy="292608"/>
+            <a:ext cx="1389888" cy="292608"/>
           </a:xfrm>
           <a:prstGeom prst="rect">
             <a:avLst/>
@@ -6705,7 +6750,7 @@
               </a:defRPr>
             </a:pPr>
             <a:r>
-              <a:t>MON–TUE</a:t>
+              <a:t>EMBEDDINGS</a:t>
             </a:r>
           </a:p>
         </p:txBody>
@@ -7335,7 +7380,7 @@
         <p:spPr>
           <a:xfrm>
             <a:off x="822960" y="566928"/>
-            <a:ext cx="1088136" cy="256032"/>
+            <a:ext cx="1389888" cy="256032"/>
           </a:xfrm>
           <a:prstGeom prst="rect">
             <a:avLst/>
@@ -7379,7 +7424,7 @@
         <p:spPr>
           <a:xfrm>
             <a:off x="822960" y="548640"/>
-            <a:ext cx="1088136" cy="292608"/>
+            <a:ext cx="1389888" cy="292608"/>
           </a:xfrm>
           <a:prstGeom prst="rect">
             <a:avLst/>
@@ -7401,7 +7446,7 @@
               </a:defRPr>
             </a:pPr>
             <a:r>
-              <a:t>MON–TUE</a:t>
+              <a:t>EMBEDDINGS</a:t>
             </a:r>
           </a:p>
         </p:txBody>
@@ -7437,7 +7482,7 @@
               </a:defRPr>
             </a:pPr>
             <a:r>
-              <a:t>What an embedding is — in my own words</a:t>
+              <a:t>What an embedding is</a:t>
             </a:r>
           </a:p>
         </p:txBody>
@@ -7532,14 +7577,102 @@
       </p:sp>
       <p:sp>
         <p:nvSpPr>
-          <p:cNvPr id="9" name="TextBox 8"/>
+          <p:cNvPr id="9" name="Rectangle 8"/>
+          <p:cNvSpPr/>
+          <p:nvPr/>
+        </p:nvSpPr>
+        <p:spPr>
+          <a:xfrm>
+            <a:off x="822960" y="1828800"/>
+            <a:ext cx="10545775" cy="384048"/>
+          </a:xfrm>
+          <a:prstGeom prst="rect">
+            <a:avLst/>
+          </a:prstGeom>
+          <a:solidFill>
+            <a:srgbClr val="FDF4E6"/>
+          </a:solidFill>
+          <a:ln>
+            <a:noFill/>
+          </a:ln>
+          <a:effectLst/>
+        </p:spPr>
+        <p:style>
+          <a:lnRef idx="1">
+            <a:schemeClr val="accent1"/>
+          </a:lnRef>
+          <a:fillRef idx="3">
+            <a:schemeClr val="accent1"/>
+          </a:fillRef>
+          <a:effectRef idx="2">
+            <a:schemeClr val="accent1"/>
+          </a:effectRef>
+          <a:fontRef idx="minor">
+            <a:schemeClr val="lt1"/>
+          </a:fontRef>
+        </p:style>
+        <p:txBody>
+          <a:bodyPr rtlCol="0" anchor="ctr"/>
+          <a:lstStyle/>
+          <a:p>
+            <a:pPr algn="ctr"/>
+          </a:p>
+        </p:txBody>
+      </p:sp>
+      <p:sp>
+        <p:nvSpPr>
+          <p:cNvPr id="10" name="Rectangle 9"/>
+          <p:cNvSpPr/>
+          <p:nvPr/>
+        </p:nvSpPr>
+        <p:spPr>
+          <a:xfrm>
+            <a:off x="822960" y="1828800"/>
+            <a:ext cx="63500" cy="384048"/>
+          </a:xfrm>
+          <a:prstGeom prst="rect">
+            <a:avLst/>
+          </a:prstGeom>
+          <a:solidFill>
+            <a:srgbClr val="B56E0C"/>
+          </a:solidFill>
+          <a:ln>
+            <a:noFill/>
+          </a:ln>
+          <a:effectLst/>
+        </p:spPr>
+        <p:style>
+          <a:lnRef idx="1">
+            <a:schemeClr val="accent1"/>
+          </a:lnRef>
+          <a:fillRef idx="3">
+            <a:schemeClr val="accent1"/>
+          </a:fillRef>
+          <a:effectRef idx="2">
+            <a:schemeClr val="accent1"/>
+          </a:effectRef>
+          <a:fontRef idx="minor">
+            <a:schemeClr val="lt1"/>
+          </a:fontRef>
+        </p:style>
+        <p:txBody>
+          <a:bodyPr rtlCol="0" anchor="ctr"/>
+          <a:lstStyle/>
+          <a:p>
+            <a:pPr algn="ctr"/>
+          </a:p>
+        </p:txBody>
+      </p:sp>
+      <p:sp>
+        <p:nvSpPr>
+          <p:cNvPr id="11" name="TextBox 10"/>
           <p:cNvSpPr txBox="1"/>
           <p:nvPr/>
         </p:nvSpPr>
         <p:spPr>
           <a:xfrm>
-            <a:off x="822960" y="1828800"/>
-            <a:ext cx="10545775" cy="3977640"/>
+            <a:off x="1024128" y="1865376"/>
+            <a:ext cx="10180015" cy="310896"/>
           </a:xfrm>
           <a:prstGeom prst="rect">
             <a:avLst/>
@@ -7547,37 +7680,52 @@
           <a:noFill/>
         </p:spPr>
         <p:txBody>
-          <a:bodyPr wrap="square" anchor="t">
+          <a:bodyPr wrap="square">
             <a:spAutoFit/>
           </a:bodyPr>
           <a:lstStyle/>
           <a:p>
             <a:pPr>
-              <a:spcAft>
-                <a:spcPts val="1500"/>
-              </a:spcAft>
-              <a:defRPr sz="2000" b="1">
+              <a:defRPr sz="1400" b="1">
                 <a:solidFill>
-                  <a:srgbClr val="0F2A44"/>
+                  <a:srgbClr val="B56E0C"/>
                 </a:solidFill>
                 <a:latin typeface="Segoe UI"/>
               </a:defRPr>
             </a:pPr>
             <a:r>
-              <a:t>[ I fill this in before presenting ]</a:t>
-            </a:r>
-          </a:p>
-          <a:p>
-            <a:pPr>
-              <a:defRPr sz="900"/>
-            </a:pPr>
-          </a:p>
+              <a:t>DRAFT — rewrite this in my own voice before presenting, then delete this strip</a:t>
+            </a:r>
+          </a:p>
+        </p:txBody>
+      </p:sp>
+      <p:sp>
+        <p:nvSpPr>
+          <p:cNvPr id="12" name="TextBox 11"/>
+          <p:cNvSpPr txBox="1"/>
+          <p:nvPr/>
+        </p:nvSpPr>
+        <p:spPr>
+          <a:xfrm>
+            <a:off x="822960" y="2487168"/>
+            <a:ext cx="10545775" cy="3319272"/>
+          </a:xfrm>
+          <a:prstGeom prst="rect">
+            <a:avLst/>
+          </a:prstGeom>
+          <a:noFill/>
+        </p:spPr>
+        <p:txBody>
+          <a:bodyPr wrap="square">
+            <a:spAutoFit/>
+          </a:bodyPr>
+          <a:lstStyle/>
           <a:p>
             <a:pPr>
               <a:spcAft>
-                <a:spcPts val="1500"/>
+                <a:spcPts val="1600"/>
               </a:spcAft>
-              <a:defRPr sz="2000" b="0">
+              <a:defRPr sz="2000">
                 <a:solidFill>
                   <a:srgbClr val="1B1B1B"/>
                 </a:solidFill>
@@ -7585,78 +7733,62 @@
               </a:defRPr>
             </a:pPr>
             <a:r>
-              <a:t>•   Your self-check: explain it without using "vector" as a cop-out</a:t>
+              <a:t>An embedding is what you get when a model reads text and turns it into a position on a map of meaning.</a:t>
             </a:r>
           </a:p>
           <a:p>
             <a:pPr>
               <a:spcAft>
-                <a:spcPts val="1500"/>
+                <a:spcPts val="1600"/>
               </a:spcAft>
-              <a:defRPr sz="2000" b="1">
+              <a:defRPr sz="2000">
                 <a:solidFill>
-                  <a:srgbClr val="0F2A44"/>
+                  <a:srgbClr val="1B1B1B"/>
                 </a:solidFill>
                 <a:latin typeface="Segoe UI"/>
               </a:defRPr>
             </a:pPr>
             <a:r>
-              <a:t>What I have to work with:</a:t>
-            </a:r>
-          </a:p>
-          <a:p>
-            <a:pPr lvl="1">
+              <a:t>Text that means similar things lands in nearby positions, even when the actual words are completely different.</a:t>
+            </a:r>
+          </a:p>
+          <a:p>
+            <a:pPr>
               <a:spcAft>
-                <a:spcPts val="1500"/>
+                <a:spcPts val="1600"/>
               </a:spcAft>
-              <a:defRPr sz="1700" b="0">
+              <a:defRPr sz="2000">
                 <a:solidFill>
-                  <a:srgbClr val="6B7280"/>
+                  <a:srgbClr val="1B1B1B"/>
                 </a:solidFill>
                 <a:latin typeface="Segoe UI"/>
               </a:defRPr>
             </a:pPr>
             <a:r>
-              <a:t>–   7 characters in and 196 characters in both give exactly 384 numbers out</a:t>
-            </a:r>
-          </a:p>
-          <a:p>
-            <a:pPr lvl="1">
+              <a:t>The model worked out the layout of that map during training, so nobody chose what each number stands for — and one number on its own tells you nothing.</a:t>
+            </a:r>
+          </a:p>
+          <a:p>
+            <a:pPr>
               <a:spcAft>
-                <a:spcPts val="1500"/>
+                <a:spcPts val="1600"/>
               </a:spcAft>
-              <a:defRPr sz="1700" b="0">
+              <a:defRPr sz="2000">
                 <a:solidFill>
-                  <a:srgbClr val="6B7280"/>
+                  <a:srgbClr val="1B1B1B"/>
                 </a:solidFill>
                 <a:latin typeface="Segoe UI"/>
               </a:defRPr>
             </a:pPr>
             <a:r>
-              <a:t>–   Two sentences with no shared words scored 0.618</a:t>
-            </a:r>
-          </a:p>
-          <a:p>
-            <a:pPr lvl="1">
-              <a:spcAft>
-                <a:spcPts val="1500"/>
-              </a:spcAft>
-              <a:defRPr sz="1700" b="0">
-                <a:solidFill>
-                  <a:srgbClr val="6B7280"/>
-                </a:solidFill>
-                <a:latin typeface="Segoe UI"/>
-              </a:defRPr>
-            </a:pPr>
-            <a:r>
-              <a:t>–   The numbers mean nothing alone — only their positions relative to each other</a:t>
-            </a:r>
-          </a:p>
-        </p:txBody>
-      </p:sp>
-      <p:sp>
-        <p:nvSpPr>
-          <p:cNvPr id="10" name="TextBox 9"/>
+              <a:t>What carries the information is how close two pieces of text end up to each other.</a:t>
+            </a:r>
+          </a:p>
+        </p:txBody>
+      </p:sp>
+      <p:sp>
+        <p:nvSpPr>
+          <p:cNvPr id="13" name="TextBox 12"/>
           <p:cNvSpPr txBox="1"/>
           <p:nvPr/>
         </p:nvSpPr>
@@ -7685,7 +7817,7 @@
               </a:defRPr>
             </a:pPr>
             <a:r>
-              <a:t>Left blank on purpose — this one has to be mine, or it falls apart when you ask a follow-up</a:t>
+              <a:t>Evidence: 7 characters and 196 characters both produce exactly 384 numbers; two sentences with no shared words scored 0.618</a:t>
             </a:r>
           </a:p>
         </p:txBody>
@@ -7797,7 +7929,7 @@
         <p:spPr>
           <a:xfrm>
             <a:off x="822960" y="566928"/>
-            <a:ext cx="1088136" cy="256032"/>
+            <a:ext cx="1188720" cy="256032"/>
           </a:xfrm>
           <a:prstGeom prst="rect">
             <a:avLst/>
@@ -7841,7 +7973,7 @@
         <p:spPr>
           <a:xfrm>
             <a:off x="822960" y="548640"/>
-            <a:ext cx="1088136" cy="292608"/>
+            <a:ext cx="1188720" cy="292608"/>
           </a:xfrm>
           <a:prstGeom prst="rect">
             <a:avLst/>
@@ -7863,7 +7995,7 @@
               </a:defRPr>
             </a:pPr>
             <a:r>
-              <a:t>WED–THU</a:t>
+              <a:t>CHUNKING</a:t>
             </a:r>
           </a:p>
         </p:txBody>
@@ -8493,7 +8625,7 @@
         <p:spPr>
           <a:xfrm>
             <a:off x="822960" y="566928"/>
-            <a:ext cx="1088136" cy="256032"/>
+            <a:ext cx="1188720" cy="256032"/>
           </a:xfrm>
           <a:prstGeom prst="rect">
             <a:avLst/>
@@ -8537,7 +8669,7 @@
         <p:spPr>
           <a:xfrm>
             <a:off x="822960" y="548640"/>
-            <a:ext cx="1088136" cy="292608"/>
+            <a:ext cx="1188720" cy="292608"/>
           </a:xfrm>
           <a:prstGeom prst="rect">
             <a:avLst/>
@@ -8559,7 +8691,7 @@
               </a:defRPr>
             </a:pPr>
             <a:r>
-              <a:t>WED–THU</a:t>
+              <a:t>CHUNKING</a:t>
             </a:r>
           </a:p>
         </p:txBody>
@@ -9334,7 +9466,7 @@
         <p:spPr>
           <a:xfrm>
             <a:off x="822960" y="566928"/>
-            <a:ext cx="685800" cy="256032"/>
+            <a:ext cx="987552" cy="256032"/>
           </a:xfrm>
           <a:prstGeom prst="rect">
             <a:avLst/>
@@ -9378,7 +9510,7 @@
         <p:spPr>
           <a:xfrm>
             <a:off x="822960" y="548640"/>
-            <a:ext cx="685800" cy="292608"/>
+            <a:ext cx="987552" cy="292608"/>
           </a:xfrm>
           <a:prstGeom prst="rect">
             <a:avLst/>
@@ -9400,7 +9532,7 @@
               </a:defRPr>
             </a:pPr>
             <a:r>
-              <a:t>FRI</a:t>
+              <a:t>SEARCH</a:t>
             </a:r>
           </a:p>
         </p:txBody>
@@ -9863,7 +9995,7 @@
         <p:spPr>
           <a:xfrm>
             <a:off x="822960" y="566928"/>
-            <a:ext cx="685800" cy="256032"/>
+            <a:ext cx="1289304" cy="256032"/>
           </a:xfrm>
           <a:prstGeom prst="rect">
             <a:avLst/>
@@ -9907,7 +10039,7 @@
         <p:spPr>
           <a:xfrm>
             <a:off x="822960" y="548640"/>
-            <a:ext cx="685800" cy="292608"/>
+            <a:ext cx="1289304" cy="292608"/>
           </a:xfrm>
           <a:prstGeom prst="rect">
             <a:avLst/>
@@ -9929,7 +10061,7 @@
               </a:defRPr>
             </a:pPr>
             <a:r>
-              <a:t>FRI</a:t>
+              <a:t>EDGE CASE</a:t>
             </a:r>
           </a:p>
         </p:txBody>

</xml_diff>